<commit_message>
fix: Folie 2 ohne Negativ-Statistik, positives AB-SOFORT-Band (AB-Feedback)
- Generator: momente.stat optional, neu momente.band (drei positive Aussagen
  im dunklen Band). Kunde wird auf Folien nie schlecht dargestellt.
- Finelli-Konfig + Vorlage auf band umgestellt, ANLEITUNG mit neuer Stil-Regel.

Co-Authored-By: Claude Fable 5 <noreply@anthropic.com>
</commit_message>
<xml_diff>
--- a/vorlagen/praesentation/vorlage-kunden-praesentation.pptx
+++ b/vorlagen/praesentation/vorlage-kunden-praesentation.pptx
@@ -6706,8 +6706,8 @@
         </p:nvSpPr>
         <p:spPr>
           <a:xfrm>
-            <a:off x="914400" y="4709160"/>
-            <a:ext cx="3566160" cy="1097280"/>
+            <a:off x="914400" y="4526280"/>
+            <a:ext cx="2743200" cy="457200"/>
           </a:xfrm>
           <a:prstGeom prst="rect">
             <a:avLst/>
@@ -6726,112 +6726,27 @@
               </a:spcAft>
             </a:pPr>
             <a:r>
-              <a:rPr sz="3800" b="1">
-                <a:solidFill>
-                  <a:srgbClr val="FFFFFF"/>
-                </a:solidFill>
-                <a:latin typeface="Georgia"/>
-              </a:rPr>
-              <a:t>{ZAHL}</a:t>
-            </a:r>
-          </a:p>
-        </p:txBody>
-      </p:sp>
-      <p:sp>
-        <p:nvSpPr>
-          <p:cNvPr id="14" name="TextBox 13"/>
-          <p:cNvSpPr txBox="1"/>
-          <p:nvPr/>
-        </p:nvSpPr>
-        <p:spPr>
-          <a:xfrm>
-            <a:off x="4389120" y="4663440"/>
-            <a:ext cx="6949440" cy="548640"/>
-          </a:xfrm>
-          <a:prstGeom prst="rect">
-            <a:avLst/>
-          </a:prstGeom>
-          <a:noFill/>
-        </p:spPr>
-        <p:txBody>
-          <a:bodyPr wrap="square" anchor="t">
-            <a:spAutoFit/>
-          </a:bodyPr>
-          <a:lstStyle/>
-          <a:p>
-            <a:pPr algn="l">
-              <a:spcAft>
-                <a:spcPts val="600"/>
-              </a:spcAft>
-            </a:pPr>
-            <a:r>
-              <a:rPr sz="1600" b="1">
-                <a:solidFill>
-                  <a:srgbClr val="FFFFFF"/>
-                </a:solidFill>
-                <a:latin typeface="Segoe UI"/>
-              </a:rPr>
-              <a:t>{Aussage zur Zahl. Nur LIVE belegte Zahlen verwenden.}</a:t>
-            </a:r>
-          </a:p>
-        </p:txBody>
-      </p:sp>
-      <p:sp>
-        <p:nvSpPr>
-          <p:cNvPr id="15" name="Rounded Rectangle 14"/>
+              <a:rPr sz="1300" b="1">
+                <a:solidFill>
+                  <a:srgbClr val="F0C9C3"/>
+                </a:solidFill>
+                <a:latin typeface="Segoe UI"/>
+              </a:rPr>
+              <a:t>AB SOFORT</a:t>
+            </a:r>
+          </a:p>
+        </p:txBody>
+      </p:sp>
+      <p:sp>
+        <p:nvSpPr>
+          <p:cNvPr id="14" name="Rounded Rectangle 13"/>
           <p:cNvSpPr/>
           <p:nvPr/>
         </p:nvSpPr>
         <p:spPr>
           <a:xfrm>
-            <a:off x="4389120" y="5349240"/>
-            <a:ext cx="6035040" cy="274320"/>
-          </a:xfrm>
-          <a:prstGeom prst="roundRect">
-            <a:avLst>
-              <a:gd name="adj" fmla="val 50000"/>
-            </a:avLst>
-          </a:prstGeom>
-          <a:solidFill>
-            <a:srgbClr val="3A3841"/>
-          </a:solidFill>
-          <a:ln>
-            <a:noFill/>
-          </a:ln>
-          <a:effectLst/>
-        </p:spPr>
-        <p:style>
-          <a:lnRef idx="1">
-            <a:schemeClr val="accent1"/>
-          </a:lnRef>
-          <a:fillRef idx="3">
-            <a:schemeClr val="accent1"/>
-          </a:fillRef>
-          <a:effectRef idx="2">
-            <a:schemeClr val="accent1"/>
-          </a:effectRef>
-          <a:fontRef idx="minor">
-            <a:schemeClr val="lt1"/>
-          </a:fontRef>
-        </p:style>
-        <p:txBody>
-          <a:bodyPr rtlCol="0" anchor="ctr"/>
-          <a:lstStyle/>
-          <a:p>
-            <a:pPr algn="ctr"/>
-          </a:p>
-        </p:txBody>
-      </p:sp>
-      <p:sp>
-        <p:nvSpPr>
-          <p:cNvPr id="16" name="Rounded Rectangle 15"/>
-          <p:cNvSpPr/>
-          <p:nvPr/>
-        </p:nvSpPr>
-        <p:spPr>
-          <a:xfrm>
-            <a:off x="4389120" y="5349240"/>
-            <a:ext cx="3621024" cy="274320"/>
+            <a:off x="914400" y="5029200"/>
+            <a:ext cx="109728" cy="685800"/>
           </a:xfrm>
           <a:prstGeom prst="roundRect">
             <a:avLst>
@@ -6870,14 +6785,14 @@
       </p:sp>
       <p:sp>
         <p:nvSpPr>
-          <p:cNvPr id="17" name="TextBox 16"/>
+          <p:cNvPr id="15" name="TextBox 14"/>
           <p:cNvSpPr txBox="1"/>
           <p:nvPr/>
         </p:nvSpPr>
         <p:spPr>
           <a:xfrm>
-            <a:off x="4389120" y="5760720"/>
-            <a:ext cx="6949440" cy="365760"/>
+            <a:off x="1188720" y="5029200"/>
+            <a:ext cx="3154680" cy="1005840"/>
           </a:xfrm>
           <a:prstGeom prst="rect">
             <a:avLst/>
@@ -6896,13 +6811,183 @@
               </a:spcAft>
             </a:pPr>
             <a:r>
-              <a:rPr sz="1050" b="0">
-                <a:solidFill>
-                  <a:srgbClr val="9A97A0"/>
-                </a:solidFill>
-                <a:latin typeface="Segoe UI"/>
-              </a:rPr>
-              <a:t>Quelle: {QUELLE JAHR}</a:t>
+              <a:rPr sz="1600" b="1">
+                <a:solidFill>
+                  <a:srgbClr val="FFFFFF"/>
+                </a:solidFill>
+                <a:latin typeface="Segoe UI"/>
+              </a:rPr>
+              <a:t>{LOESUNG_1. Positiv, kurz.}</a:t>
+            </a:r>
+          </a:p>
+        </p:txBody>
+      </p:sp>
+      <p:sp>
+        <p:nvSpPr>
+          <p:cNvPr id="16" name="Rounded Rectangle 15"/>
+          <p:cNvSpPr/>
+          <p:nvPr/>
+        </p:nvSpPr>
+        <p:spPr>
+          <a:xfrm>
+            <a:off x="4480560" y="5029200"/>
+            <a:ext cx="109728" cy="685800"/>
+          </a:xfrm>
+          <a:prstGeom prst="roundRect">
+            <a:avLst>
+              <a:gd name="adj" fmla="val 50000"/>
+            </a:avLst>
+          </a:prstGeom>
+          <a:solidFill>
+            <a:srgbClr val="1F3A5F"/>
+          </a:solidFill>
+          <a:ln>
+            <a:noFill/>
+          </a:ln>
+          <a:effectLst/>
+        </p:spPr>
+        <p:style>
+          <a:lnRef idx="1">
+            <a:schemeClr val="accent1"/>
+          </a:lnRef>
+          <a:fillRef idx="3">
+            <a:schemeClr val="accent1"/>
+          </a:fillRef>
+          <a:effectRef idx="2">
+            <a:schemeClr val="accent1"/>
+          </a:effectRef>
+          <a:fontRef idx="minor">
+            <a:schemeClr val="lt1"/>
+          </a:fontRef>
+        </p:style>
+        <p:txBody>
+          <a:bodyPr rtlCol="0" anchor="ctr"/>
+          <a:lstStyle/>
+          <a:p>
+            <a:pPr algn="ctr"/>
+          </a:p>
+        </p:txBody>
+      </p:sp>
+      <p:sp>
+        <p:nvSpPr>
+          <p:cNvPr id="17" name="TextBox 16"/>
+          <p:cNvSpPr txBox="1"/>
+          <p:nvPr/>
+        </p:nvSpPr>
+        <p:spPr>
+          <a:xfrm>
+            <a:off x="4754880" y="5029200"/>
+            <a:ext cx="3154680" cy="1005840"/>
+          </a:xfrm>
+          <a:prstGeom prst="rect">
+            <a:avLst/>
+          </a:prstGeom>
+          <a:noFill/>
+        </p:spPr>
+        <p:txBody>
+          <a:bodyPr wrap="square" anchor="t">
+            <a:spAutoFit/>
+          </a:bodyPr>
+          <a:lstStyle/>
+          <a:p>
+            <a:pPr algn="l">
+              <a:spcAft>
+                <a:spcPts val="600"/>
+              </a:spcAft>
+            </a:pPr>
+            <a:r>
+              <a:rPr sz="1600" b="1">
+                <a:solidFill>
+                  <a:srgbClr val="FFFFFF"/>
+                </a:solidFill>
+                <a:latin typeface="Segoe UI"/>
+              </a:rPr>
+              <a:t>{LOESUNG_2}</a:t>
+            </a:r>
+          </a:p>
+        </p:txBody>
+      </p:sp>
+      <p:sp>
+        <p:nvSpPr>
+          <p:cNvPr id="18" name="Rounded Rectangle 17"/>
+          <p:cNvSpPr/>
+          <p:nvPr/>
+        </p:nvSpPr>
+        <p:spPr>
+          <a:xfrm>
+            <a:off x="8046720" y="5029200"/>
+            <a:ext cx="109728" cy="685800"/>
+          </a:xfrm>
+          <a:prstGeom prst="roundRect">
+            <a:avLst>
+              <a:gd name="adj" fmla="val 50000"/>
+            </a:avLst>
+          </a:prstGeom>
+          <a:solidFill>
+            <a:srgbClr val="1F3A5F"/>
+          </a:solidFill>
+          <a:ln>
+            <a:noFill/>
+          </a:ln>
+          <a:effectLst/>
+        </p:spPr>
+        <p:style>
+          <a:lnRef idx="1">
+            <a:schemeClr val="accent1"/>
+          </a:lnRef>
+          <a:fillRef idx="3">
+            <a:schemeClr val="accent1"/>
+          </a:fillRef>
+          <a:effectRef idx="2">
+            <a:schemeClr val="accent1"/>
+          </a:effectRef>
+          <a:fontRef idx="minor">
+            <a:schemeClr val="lt1"/>
+          </a:fontRef>
+        </p:style>
+        <p:txBody>
+          <a:bodyPr rtlCol="0" anchor="ctr"/>
+          <a:lstStyle/>
+          <a:p>
+            <a:pPr algn="ctr"/>
+          </a:p>
+        </p:txBody>
+      </p:sp>
+      <p:sp>
+        <p:nvSpPr>
+          <p:cNvPr id="19" name="TextBox 18"/>
+          <p:cNvSpPr txBox="1"/>
+          <p:nvPr/>
+        </p:nvSpPr>
+        <p:spPr>
+          <a:xfrm>
+            <a:off x="8321040" y="5029200"/>
+            <a:ext cx="3154680" cy="1005840"/>
+          </a:xfrm>
+          <a:prstGeom prst="rect">
+            <a:avLst/>
+          </a:prstGeom>
+          <a:noFill/>
+        </p:spPr>
+        <p:txBody>
+          <a:bodyPr wrap="square" anchor="t">
+            <a:spAutoFit/>
+          </a:bodyPr>
+          <a:lstStyle/>
+          <a:p>
+            <a:pPr algn="l">
+              <a:spcAft>
+                <a:spcPts val="600"/>
+              </a:spcAft>
+            </a:pPr>
+            <a:r>
+              <a:rPr sz="1600" b="1">
+                <a:solidFill>
+                  <a:srgbClr val="FFFFFF"/>
+                </a:solidFill>
+                <a:latin typeface="Segoe UI"/>
+              </a:rPr>
+              <a:t>{LOESUNG_3}</a:t>
             </a:r>
           </a:p>
         </p:txBody>

</xml_diff>